<commit_message>
Add business value section, presentation, fix model auto-download fallback
</commit_message>
<xml_diff>
--- a/VLM_Project_Presentation.pptx
+++ b/VLM_Project_Presentation.pptx
@@ -10,10 +10,9 @@
     <p:sldId id="258" r:id="rId4"/>
     <p:sldId id="259" r:id="rId5"/>
     <p:sldId id="260" r:id="rId6"/>
-    <p:sldId id="261" r:id="rId7"/>
-    <p:sldId id="262" r:id="rId8"/>
-    <p:sldId id="263" r:id="rId9"/>
-    <p:sldId id="264" r:id="rId10"/>
+    <p:sldId id="262" r:id="rId7"/>
+    <p:sldId id="263" r:id="rId8"/>
+    <p:sldId id="264" r:id="rId9"/>
   </p:sldIdLst>
   <p:sldSz cx="12192000" cy="6858000"/>
   <p:notesSz cx="6858000" cy="9144000"/>
@@ -5350,7 +5349,7 @@
               </a:defRPr>
             </a:pPr>
             <a:r>
-              <a:t>Архитектура решения</a:t>
+              <a:t>Результаты</a:t>
             </a:r>
           </a:p>
         </p:txBody>
@@ -5363,360 +5362,485 @@
         </p:nvSpPr>
         <p:spPr>
           <a:xfrm>
-            <a:off x="731520" y="1097280"/>
-            <a:ext cx="10972800" cy="5029200"/>
-          </a:xfrm>
-          <a:prstGeom prst="rect">
-            <a:avLst/>
-          </a:prstGeom>
-          <a:noFill/>
-        </p:spPr>
-        <p:txBody>
-          <a:bodyPr wrap="square">
-            <a:spAutoFit/>
-          </a:bodyPr>
-          <a:lstStyle/>
-          <a:p>
-            <a:br>
-              <a:rPr dirty="0">
-                <a:solidFill>
-                  <a:schemeClr val="bg1"/>
-                </a:solidFill>
-              </a:rPr>
-            </a:br>
-            <a:r>
-              <a:rPr dirty="0" err="1">
-                <a:solidFill>
-                  <a:schemeClr val="bg1"/>
-                </a:solidFill>
-              </a:rPr>
-              <a:t>LLaVA</a:t>
-            </a:r>
-            <a:r>
-              <a:rPr dirty="0">
-                <a:solidFill>
-                  <a:schemeClr val="bg1"/>
-                </a:solidFill>
-              </a:rPr>
-              <a:t> For Conditional Generation</a:t>
-            </a:r>
-            <a:br>
-              <a:rPr dirty="0">
-                <a:solidFill>
-                  <a:schemeClr val="bg1"/>
-                </a:solidFill>
-              </a:rPr>
-            </a:br>
-            <a:r>
-              <a:rPr dirty="0">
-                <a:solidFill>
-                  <a:schemeClr val="bg1"/>
-                </a:solidFill>
-              </a:rPr>
-              <a:t>┌──────────────────────────────────────────────────┐</a:t>
-            </a:r>
-            <a:br>
-              <a:rPr dirty="0">
-                <a:solidFill>
-                  <a:schemeClr val="bg1"/>
-                </a:solidFill>
-              </a:rPr>
-            </a:br>
-            <a:r>
-              <a:rPr dirty="0">
-                <a:solidFill>
-                  <a:schemeClr val="bg1"/>
-                </a:solidFill>
-              </a:rPr>
-              <a:t>│  ┌──────────────┐     ┌────────────────────────┐ │</a:t>
-            </a:r>
-            <a:br>
-              <a:rPr dirty="0">
-                <a:solidFill>
-                  <a:schemeClr val="bg1"/>
-                </a:solidFill>
-              </a:rPr>
-            </a:br>
-            <a:r>
-              <a:rPr dirty="0">
-                <a:solidFill>
-                  <a:schemeClr val="bg1"/>
-                </a:solidFill>
-              </a:rPr>
-              <a:t>│  │ Vision Encoder│     │   Gemma-2B (LM)        │ │</a:t>
-            </a:r>
-            <a:br>
-              <a:rPr dirty="0">
-                <a:solidFill>
-                  <a:schemeClr val="bg1"/>
-                </a:solidFill>
-              </a:rPr>
-            </a:br>
-            <a:r>
-              <a:rPr dirty="0">
-                <a:solidFill>
-                  <a:schemeClr val="bg1"/>
-                </a:solidFill>
-              </a:rPr>
-              <a:t>│  │  (frozen)    │────→│  ┌──────────────────┐  │ │</a:t>
-            </a:r>
-            <a:br>
-              <a:rPr dirty="0">
-                <a:solidFill>
-                  <a:schemeClr val="bg1"/>
-                </a:solidFill>
-              </a:rPr>
-            </a:br>
-            <a:r>
-              <a:rPr dirty="0">
-                <a:solidFill>
-                  <a:schemeClr val="bg1"/>
-                </a:solidFill>
-              </a:rPr>
-              <a:t>│  │  </a:t>
-            </a:r>
-            <a:r>
-              <a:rPr dirty="0" err="1">
-                <a:solidFill>
-                  <a:schemeClr val="bg1"/>
-                </a:solidFill>
-              </a:rPr>
-              <a:t>SigLIP</a:t>
-            </a:r>
-            <a:r>
-              <a:rPr dirty="0">
-                <a:solidFill>
-                  <a:schemeClr val="bg1"/>
-                </a:solidFill>
-              </a:rPr>
-              <a:t>      │     │  │ 4-bit NF4 weights │  │ │</a:t>
-            </a:r>
-            <a:br>
-              <a:rPr dirty="0">
-                <a:solidFill>
-                  <a:schemeClr val="bg1"/>
-                </a:solidFill>
-              </a:rPr>
-            </a:br>
-            <a:r>
-              <a:rPr dirty="0">
-                <a:solidFill>
-                  <a:schemeClr val="bg1"/>
-                </a:solidFill>
-              </a:rPr>
-              <a:t>│  └──────────────┘     │  │ (frozen)          │  │ │</a:t>
-            </a:r>
-            <a:br>
-              <a:rPr dirty="0">
-                <a:solidFill>
-                  <a:schemeClr val="bg1"/>
-                </a:solidFill>
-              </a:rPr>
-            </a:br>
-            <a:r>
-              <a:rPr dirty="0">
-                <a:solidFill>
-                  <a:schemeClr val="bg1"/>
-                </a:solidFill>
-              </a:rPr>
-              <a:t>│                       │  ├──────────────────┤  │ │</a:t>
-            </a:r>
-            <a:br>
-              <a:rPr dirty="0">
-                <a:solidFill>
-                  <a:schemeClr val="bg1"/>
-                </a:solidFill>
-              </a:rPr>
-            </a:br>
-            <a:r>
-              <a:rPr dirty="0">
-                <a:solidFill>
-                  <a:schemeClr val="bg1"/>
-                </a:solidFill>
-              </a:rPr>
-              <a:t>│  ┌──────────────┐     │  │ </a:t>
-            </a:r>
-            <a:r>
-              <a:rPr dirty="0" err="1">
-                <a:solidFill>
-                  <a:schemeClr val="bg1"/>
-                </a:solidFill>
-              </a:rPr>
-              <a:t>LoRA</a:t>
-            </a:r>
-            <a:r>
-              <a:rPr dirty="0">
-                <a:solidFill>
-                  <a:schemeClr val="bg1"/>
-                </a:solidFill>
-              </a:rPr>
-              <a:t> adapters     │  │ │</a:t>
-            </a:r>
-            <a:br>
-              <a:rPr dirty="0">
-                <a:solidFill>
-                  <a:schemeClr val="bg1"/>
-                </a:solidFill>
-              </a:rPr>
-            </a:br>
-            <a:r>
-              <a:rPr dirty="0">
-                <a:solidFill>
-                  <a:schemeClr val="bg1"/>
-                </a:solidFill>
-              </a:rPr>
-              <a:t>│  │  Projection   │     │  │ (trainable)      │  │ │</a:t>
-            </a:r>
-            <a:br>
-              <a:rPr dirty="0">
-                <a:solidFill>
-                  <a:schemeClr val="bg1"/>
-                </a:solidFill>
-              </a:rPr>
-            </a:br>
-            <a:r>
-              <a:rPr dirty="0">
-                <a:solidFill>
-                  <a:schemeClr val="bg1"/>
-                </a:solidFill>
-              </a:rPr>
-              <a:t>│  │  (frozen)    │     │  │ r=16, α=32       │  │ │</a:t>
-            </a:r>
-            <a:br>
-              <a:rPr dirty="0">
-                <a:solidFill>
-                  <a:schemeClr val="bg1"/>
-                </a:solidFill>
-              </a:rPr>
-            </a:br>
-            <a:r>
-              <a:rPr dirty="0">
-                <a:solidFill>
-                  <a:schemeClr val="bg1"/>
-                </a:solidFill>
-              </a:rPr>
-              <a:t>│  └──────────────┘     │  └──────────────────┘  │ │</a:t>
-            </a:r>
-            <a:br>
-              <a:rPr dirty="0">
-                <a:solidFill>
-                  <a:schemeClr val="bg1"/>
-                </a:solidFill>
-              </a:rPr>
-            </a:br>
-            <a:r>
-              <a:rPr dirty="0">
-                <a:solidFill>
-                  <a:schemeClr val="bg1"/>
-                </a:solidFill>
-              </a:rPr>
-              <a:t>│                       └────────────────────────┘ │</a:t>
-            </a:r>
-            <a:br>
-              <a:rPr dirty="0">
-                <a:solidFill>
-                  <a:schemeClr val="bg1"/>
-                </a:solidFill>
-              </a:rPr>
-            </a:br>
-            <a:r>
-              <a:rPr dirty="0">
-                <a:solidFill>
-                  <a:schemeClr val="bg1"/>
-                </a:solidFill>
-              </a:rPr>
-              <a:t>└──────────────────────────────────────────────────┘</a:t>
-            </a:r>
-            <a:br>
-              <a:rPr dirty="0">
-                <a:solidFill>
-                  <a:schemeClr val="bg1"/>
-                </a:solidFill>
-              </a:rPr>
-            </a:br>
-            <a:br>
-              <a:rPr dirty="0">
-                <a:solidFill>
-                  <a:schemeClr val="bg1"/>
-                </a:solidFill>
-              </a:rPr>
-            </a:br>
-            <a:r>
-              <a:rPr dirty="0" err="1">
-                <a:solidFill>
-                  <a:schemeClr val="bg1"/>
-                </a:solidFill>
-              </a:rPr>
-              <a:t>Пайплайн</a:t>
-            </a:r>
-            <a:r>
-              <a:rPr dirty="0">
-                <a:solidFill>
-                  <a:schemeClr val="bg1"/>
-                </a:solidFill>
-              </a:rPr>
-              <a:t>: EDA → </a:t>
-            </a:r>
-            <a:r>
-              <a:rPr dirty="0" err="1">
-                <a:solidFill>
-                  <a:schemeClr val="bg1"/>
-                </a:solidFill>
-              </a:rPr>
-              <a:t>Подготовка</a:t>
-            </a:r>
-            <a:r>
-              <a:rPr dirty="0">
-                <a:solidFill>
-                  <a:schemeClr val="bg1"/>
-                </a:solidFill>
-              </a:rPr>
-              <a:t> </a:t>
-            </a:r>
-            <a:r>
-              <a:rPr dirty="0" err="1">
-                <a:solidFill>
-                  <a:schemeClr val="bg1"/>
-                </a:solidFill>
-              </a:rPr>
-              <a:t>данных</a:t>
-            </a:r>
-            <a:r>
-              <a:rPr dirty="0">
-                <a:solidFill>
-                  <a:schemeClr val="bg1"/>
-                </a:solidFill>
-              </a:rPr>
-              <a:t> → </a:t>
-            </a:r>
-            <a:r>
-              <a:rPr dirty="0" err="1">
-                <a:solidFill>
-                  <a:schemeClr val="bg1"/>
-                </a:solidFill>
-              </a:rPr>
-              <a:t>QLoRA</a:t>
-            </a:r>
-            <a:r>
-              <a:rPr dirty="0">
-                <a:solidFill>
-                  <a:schemeClr val="bg1"/>
-                </a:solidFill>
-              </a:rPr>
-              <a:t> Training → Evaluation</a:t>
-            </a:r>
-            <a:br>
-              <a:rPr dirty="0">
-                <a:solidFill>
-                  <a:schemeClr val="bg1"/>
-                </a:solidFill>
-              </a:rPr>
-            </a:br>
-            <a:endParaRPr dirty="0">
-              <a:solidFill>
-                <a:schemeClr val="bg1"/>
-              </a:solidFill>
-            </a:endParaRPr>
+            <a:off x="731520" y="1188720"/>
+            <a:ext cx="10058400" cy="457200"/>
+          </a:xfrm>
+          <a:prstGeom prst="rect">
+            <a:avLst/>
+          </a:prstGeom>
+          <a:noFill/>
+        </p:spPr>
+        <p:txBody>
+          <a:bodyPr wrap="square">
+            <a:spAutoFit/>
+          </a:bodyPr>
+          <a:lstStyle/>
+          <a:p>
+            <a:pPr algn="l">
+              <a:defRPr sz="2000" b="1">
+                <a:solidFill>
+                  <a:srgbClr val="FFFFFF"/>
+                </a:solidFill>
+              </a:defRPr>
+            </a:pPr>
+            <a:r>
+              <a:t>Сравнение базовой и дообученной моделей:</a:t>
+            </a:r>
+          </a:p>
+        </p:txBody>
+      </p:sp>
+      <p:sp>
+        <p:nvSpPr>
+          <p:cNvPr id="4" name="TextBox 3"/>
+          <p:cNvSpPr txBox="1"/>
+          <p:nvPr/>
+        </p:nvSpPr>
+        <p:spPr>
+          <a:xfrm>
+            <a:off x="731520" y="2011680"/>
+            <a:ext cx="3657600" cy="365760"/>
+          </a:xfrm>
+          <a:prstGeom prst="rect">
+            <a:avLst/>
+          </a:prstGeom>
+          <a:noFill/>
+        </p:spPr>
+        <p:txBody>
+          <a:bodyPr wrap="square">
+            <a:spAutoFit/>
+          </a:bodyPr>
+          <a:lstStyle/>
+          <a:p>
+            <a:pPr algn="l">
+              <a:defRPr sz="1600" b="1">
+                <a:solidFill>
+                  <a:srgbClr val="4FC3F7"/>
+                </a:solidFill>
+              </a:defRPr>
+            </a:pPr>
+            <a:r>
+              <a:t>Модель</a:t>
+            </a:r>
+          </a:p>
+        </p:txBody>
+      </p:sp>
+      <p:sp>
+        <p:nvSpPr>
+          <p:cNvPr id="5" name="TextBox 4"/>
+          <p:cNvSpPr txBox="1"/>
+          <p:nvPr/>
+        </p:nvSpPr>
+        <p:spPr>
+          <a:xfrm>
+            <a:off x="4572000" y="2011680"/>
+            <a:ext cx="2743200" cy="365760"/>
+          </a:xfrm>
+          <a:prstGeom prst="rect">
+            <a:avLst/>
+          </a:prstGeom>
+          <a:noFill/>
+        </p:spPr>
+        <p:txBody>
+          <a:bodyPr wrap="square">
+            <a:spAutoFit/>
+          </a:bodyPr>
+          <a:lstStyle/>
+          <a:p>
+            <a:pPr algn="l">
+              <a:defRPr sz="1600" b="1">
+                <a:solidFill>
+                  <a:srgbClr val="4FC3F7"/>
+                </a:solidFill>
+              </a:defRPr>
+            </a:pPr>
+            <a:r>
+              <a:t>GQA-ru (accuracy)</a:t>
+            </a:r>
+          </a:p>
+        </p:txBody>
+      </p:sp>
+      <p:sp>
+        <p:nvSpPr>
+          <p:cNvPr id="6" name="TextBox 5"/>
+          <p:cNvSpPr txBox="1"/>
+          <p:nvPr/>
+        </p:nvSpPr>
+        <p:spPr>
+          <a:xfrm>
+            <a:off x="7772400" y="2011680"/>
+            <a:ext cx="3200400" cy="365760"/>
+          </a:xfrm>
+          <a:prstGeom prst="rect">
+            <a:avLst/>
+          </a:prstGeom>
+          <a:noFill/>
+        </p:spPr>
+        <p:txBody>
+          <a:bodyPr wrap="square">
+            <a:spAutoFit/>
+          </a:bodyPr>
+          <a:lstStyle/>
+          <a:p>
+            <a:pPr algn="l">
+              <a:defRPr sz="1600" b="1">
+                <a:solidFill>
+                  <a:srgbClr val="4FC3F7"/>
+                </a:solidFill>
+              </a:defRPr>
+            </a:pPr>
+            <a:r>
+              <a:t>MMBench-ru (accuracy)</a:t>
+            </a:r>
+          </a:p>
+        </p:txBody>
+      </p:sp>
+      <p:sp>
+        <p:nvSpPr>
+          <p:cNvPr id="7" name="TextBox 6"/>
+          <p:cNvSpPr txBox="1"/>
+          <p:nvPr/>
+        </p:nvSpPr>
+        <p:spPr>
+          <a:xfrm>
+            <a:off x="731520" y="2468880"/>
+            <a:ext cx="3657600" cy="365760"/>
+          </a:xfrm>
+          <a:prstGeom prst="rect">
+            <a:avLst/>
+          </a:prstGeom>
+          <a:noFill/>
+        </p:spPr>
+        <p:txBody>
+          <a:bodyPr wrap="square">
+            <a:spAutoFit/>
+          </a:bodyPr>
+          <a:lstStyle/>
+          <a:p>
+            <a:pPr algn="l">
+              <a:defRPr sz="1600" b="0">
+                <a:solidFill>
+                  <a:srgbClr val="FFFFFF"/>
+                </a:solidFill>
+              </a:defRPr>
+            </a:pPr>
+            <a:r>
+              <a:t>Base (без fine-tuning)</a:t>
+            </a:r>
+          </a:p>
+        </p:txBody>
+      </p:sp>
+      <p:sp>
+        <p:nvSpPr>
+          <p:cNvPr id="8" name="TextBox 7"/>
+          <p:cNvSpPr txBox="1"/>
+          <p:nvPr/>
+        </p:nvSpPr>
+        <p:spPr>
+          <a:xfrm>
+            <a:off x="4572000" y="2468880"/>
+            <a:ext cx="2743200" cy="365760"/>
+          </a:xfrm>
+          <a:prstGeom prst="rect">
+            <a:avLst/>
+          </a:prstGeom>
+          <a:noFill/>
+        </p:spPr>
+        <p:txBody>
+          <a:bodyPr wrap="square">
+            <a:spAutoFit/>
+          </a:bodyPr>
+          <a:lstStyle/>
+          <a:p>
+            <a:pPr algn="l">
+              <a:defRPr sz="1600" b="0">
+                <a:solidFill>
+                  <a:srgbClr val="E0E0E0"/>
+                </a:solidFill>
+              </a:defRPr>
+            </a:pPr>
+            <a:r>
+              <a:t>0.4700 (47/100)</a:t>
+            </a:r>
+          </a:p>
+        </p:txBody>
+      </p:sp>
+      <p:sp>
+        <p:nvSpPr>
+          <p:cNvPr id="9" name="TextBox 8"/>
+          <p:cNvSpPr txBox="1"/>
+          <p:nvPr/>
+        </p:nvSpPr>
+        <p:spPr>
+          <a:xfrm>
+            <a:off x="7772400" y="2468880"/>
+            <a:ext cx="3200400" cy="365760"/>
+          </a:xfrm>
+          <a:prstGeom prst="rect">
+            <a:avLst/>
+          </a:prstGeom>
+          <a:noFill/>
+        </p:spPr>
+        <p:txBody>
+          <a:bodyPr wrap="square">
+            <a:spAutoFit/>
+          </a:bodyPr>
+          <a:lstStyle/>
+          <a:p>
+            <a:pPr algn="l">
+              <a:defRPr sz="1600" b="0">
+                <a:solidFill>
+                  <a:srgbClr val="E0E0E0"/>
+                </a:solidFill>
+              </a:defRPr>
+            </a:pPr>
+            <a:r>
+              <a:t>0.5700 (57/100)</a:t>
+            </a:r>
+          </a:p>
+        </p:txBody>
+      </p:sp>
+      <p:sp>
+        <p:nvSpPr>
+          <p:cNvPr id="10" name="TextBox 9"/>
+          <p:cNvSpPr txBox="1"/>
+          <p:nvPr/>
+        </p:nvSpPr>
+        <p:spPr>
+          <a:xfrm>
+            <a:off x="731520" y="2926080"/>
+            <a:ext cx="3657600" cy="365760"/>
+          </a:xfrm>
+          <a:prstGeom prst="rect">
+            <a:avLst/>
+          </a:prstGeom>
+          <a:noFill/>
+        </p:spPr>
+        <p:txBody>
+          <a:bodyPr wrap="square">
+            <a:spAutoFit/>
+          </a:bodyPr>
+          <a:lstStyle/>
+          <a:p>
+            <a:pPr algn="l">
+              <a:defRPr sz="1600" b="1">
+                <a:solidFill>
+                  <a:srgbClr val="4CAF50"/>
+                </a:solidFill>
+              </a:defRPr>
+            </a:pPr>
+            <a:r>
+              <a:t>Fine-tuned (QLoRA)</a:t>
+            </a:r>
+          </a:p>
+        </p:txBody>
+      </p:sp>
+      <p:sp>
+        <p:nvSpPr>
+          <p:cNvPr id="11" name="TextBox 10"/>
+          <p:cNvSpPr txBox="1"/>
+          <p:nvPr/>
+        </p:nvSpPr>
+        <p:spPr>
+          <a:xfrm>
+            <a:off x="4572000" y="2926080"/>
+            <a:ext cx="2743200" cy="365760"/>
+          </a:xfrm>
+          <a:prstGeom prst="rect">
+            <a:avLst/>
+          </a:prstGeom>
+          <a:noFill/>
+        </p:spPr>
+        <p:txBody>
+          <a:bodyPr wrap="square">
+            <a:spAutoFit/>
+          </a:bodyPr>
+          <a:lstStyle/>
+          <a:p>
+            <a:pPr algn="l">
+              <a:defRPr sz="1600" b="0">
+                <a:solidFill>
+                  <a:srgbClr val="4CAF50"/>
+                </a:solidFill>
+              </a:defRPr>
+            </a:pPr>
+            <a:r>
+              <a:t>0.4600 (46/100)</a:t>
+            </a:r>
+          </a:p>
+        </p:txBody>
+      </p:sp>
+      <p:sp>
+        <p:nvSpPr>
+          <p:cNvPr id="12" name="TextBox 11"/>
+          <p:cNvSpPr txBox="1"/>
+          <p:nvPr/>
+        </p:nvSpPr>
+        <p:spPr>
+          <a:xfrm>
+            <a:off x="7772400" y="2926080"/>
+            <a:ext cx="3200400" cy="365760"/>
+          </a:xfrm>
+          <a:prstGeom prst="rect">
+            <a:avLst/>
+          </a:prstGeom>
+          <a:noFill/>
+        </p:spPr>
+        <p:txBody>
+          <a:bodyPr wrap="square">
+            <a:spAutoFit/>
+          </a:bodyPr>
+          <a:lstStyle/>
+          <a:p>
+            <a:pPr algn="l">
+              <a:defRPr sz="1600" b="0">
+                <a:solidFill>
+                  <a:srgbClr val="4CAF50"/>
+                </a:solidFill>
+              </a:defRPr>
+            </a:pPr>
+            <a:r>
+              <a:t>0.5700 (57/100)</a:t>
+            </a:r>
+          </a:p>
+        </p:txBody>
+      </p:sp>
+      <p:sp>
+        <p:nvSpPr>
+          <p:cNvPr id="13" name="TextBox 12"/>
+          <p:cNvSpPr txBox="1"/>
+          <p:nvPr/>
+        </p:nvSpPr>
+        <p:spPr>
+          <a:xfrm>
+            <a:off x="731520" y="3840480"/>
+            <a:ext cx="10058400" cy="457200"/>
+          </a:xfrm>
+          <a:prstGeom prst="rect">
+            <a:avLst/>
+          </a:prstGeom>
+          <a:noFill/>
+        </p:spPr>
+        <p:txBody>
+          <a:bodyPr wrap="square">
+            <a:spAutoFit/>
+          </a:bodyPr>
+          <a:lstStyle/>
+          <a:p>
+            <a:pPr algn="l">
+              <a:defRPr sz="1600" b="0">
+                <a:solidFill>
+                  <a:srgbClr val="E0E0E0"/>
+                </a:solidFill>
+              </a:defRPr>
+            </a:pPr>
+            <a:r>
+              <a:t>Train loss: 6.34 (9.3 → 5.1 за 100 шагов)</a:t>
+            </a:r>
+          </a:p>
+        </p:txBody>
+      </p:sp>
+      <p:sp>
+        <p:nvSpPr>
+          <p:cNvPr id="14" name="TextBox 13"/>
+          <p:cNvSpPr txBox="1"/>
+          <p:nvPr/>
+        </p:nvSpPr>
+        <p:spPr>
+          <a:xfrm>
+            <a:off x="731520" y="4389120"/>
+            <a:ext cx="10058400" cy="457200"/>
+          </a:xfrm>
+          <a:prstGeom prst="rect">
+            <a:avLst/>
+          </a:prstGeom>
+          <a:noFill/>
+        </p:spPr>
+        <p:txBody>
+          <a:bodyPr wrap="square">
+            <a:spAutoFit/>
+          </a:bodyPr>
+          <a:lstStyle/>
+          <a:p>
+            <a:pPr algn="l">
+              <a:defRPr sz="1600" b="0">
+                <a:solidFill>
+                  <a:srgbClr val="E0E0E0"/>
+                </a:solidFill>
+              </a:defRPr>
+            </a:pPr>
+            <a:r>
+              <a:t>VRAM: ~2.1 ГБ из 6 ГБ (RTX 4050)</a:t>
+            </a:r>
+          </a:p>
+        </p:txBody>
+      </p:sp>
+      <p:sp>
+        <p:nvSpPr>
+          <p:cNvPr id="15" name="TextBox 14"/>
+          <p:cNvSpPr txBox="1"/>
+          <p:nvPr/>
+        </p:nvSpPr>
+        <p:spPr>
+          <a:xfrm>
+            <a:off x="731520" y="4937760"/>
+            <a:ext cx="10058400" cy="457200"/>
+          </a:xfrm>
+          <a:prstGeom prst="rect">
+            <a:avLst/>
+          </a:prstGeom>
+          <a:noFill/>
+        </p:spPr>
+        <p:txBody>
+          <a:bodyPr wrap="square">
+            <a:spAutoFit/>
+          </a:bodyPr>
+          <a:lstStyle/>
+          <a:p>
+            <a:pPr algn="l">
+              <a:defRPr sz="1600" b="0">
+                <a:solidFill>
+                  <a:srgbClr val="E0E0E0"/>
+                </a:solidFill>
+              </a:defRPr>
+            </a:pPr>
+            <a:r>
+              <a:t>Обучающих примеров: 2000 из GQA-ru</a:t>
+            </a:r>
+          </a:p>
+        </p:txBody>
+      </p:sp>
+      <p:sp>
+        <p:nvSpPr>
+          <p:cNvPr id="16" name="TextBox 15"/>
+          <p:cNvSpPr txBox="1"/>
+          <p:nvPr/>
+        </p:nvSpPr>
+        <p:spPr>
+          <a:xfrm>
+            <a:off x="731520" y="5486400"/>
+            <a:ext cx="10058400" cy="457200"/>
+          </a:xfrm>
+          <a:prstGeom prst="rect">
+            <a:avLst/>
+          </a:prstGeom>
+          <a:noFill/>
+        </p:spPr>
+        <p:txBody>
+          <a:bodyPr wrap="square">
+            <a:spAutoFit/>
+          </a:bodyPr>
+          <a:lstStyle/>
+          <a:p>
+            <a:pPr algn="l">
+              <a:defRPr sz="1600" b="0">
+                <a:solidFill>
+                  <a:srgbClr val="E0E0E0"/>
+                </a:solidFill>
+              </a:defRPr>
+            </a:pPr>
+            <a:r>
+              <a:t>Trainable params: 19.6M (0.78%) из 2.5B</a:t>
+            </a:r>
           </a:p>
         </p:txBody>
       </p:sp>
@@ -5783,7 +5907,7 @@
               </a:defRPr>
             </a:pPr>
             <a:r>
-              <a:t>Результаты</a:t>
+              <a:t>Выводы и направления развития</a:t>
             </a:r>
           </a:p>
         </p:txBody>
@@ -5813,257 +5937,257 @@
             <a:pPr algn="l">
               <a:defRPr sz="2000" b="1">
                 <a:solidFill>
+                  <a:srgbClr val="4CAF50"/>
+                </a:solidFill>
+              </a:defRPr>
+            </a:pPr>
+            <a:r>
+              <a:t>Достижения:</a:t>
+            </a:r>
+          </a:p>
+        </p:txBody>
+      </p:sp>
+      <p:sp>
+        <p:nvSpPr>
+          <p:cNvPr id="4" name="TextBox 3"/>
+          <p:cNvSpPr txBox="1"/>
+          <p:nvPr/>
+        </p:nvSpPr>
+        <p:spPr>
+          <a:xfrm>
+            <a:off x="914400" y="1737360"/>
+            <a:ext cx="9601200" cy="457200"/>
+          </a:xfrm>
+          <a:prstGeom prst="rect">
+            <a:avLst/>
+          </a:prstGeom>
+          <a:noFill/>
+        </p:spPr>
+        <p:txBody>
+          <a:bodyPr wrap="square">
+            <a:spAutoFit/>
+          </a:bodyPr>
+          <a:lstStyle/>
+          <a:p>
+            <a:pPr algn="l">
+              <a:defRPr sz="1800" b="0">
+                <a:solidFill>
                   <a:srgbClr val="FFFFFF"/>
                 </a:solidFill>
               </a:defRPr>
             </a:pPr>
             <a:r>
-              <a:t>Сравнение базовой и дообученной моделей:</a:t>
-            </a:r>
-          </a:p>
-        </p:txBody>
-      </p:sp>
-      <p:sp>
-        <p:nvSpPr>
-          <p:cNvPr id="4" name="TextBox 3"/>
-          <p:cNvSpPr txBox="1"/>
-          <p:nvPr/>
-        </p:nvSpPr>
-        <p:spPr>
-          <a:xfrm>
-            <a:off x="731520" y="2011680"/>
-            <a:ext cx="3657600" cy="365760"/>
-          </a:xfrm>
-          <a:prstGeom prst="rect">
-            <a:avLst/>
-          </a:prstGeom>
-          <a:noFill/>
-        </p:spPr>
-        <p:txBody>
-          <a:bodyPr wrap="square">
-            <a:spAutoFit/>
-          </a:bodyPr>
-          <a:lstStyle/>
-          <a:p>
-            <a:pPr algn="l">
-              <a:defRPr sz="1600" b="1">
+              <a:t>✓ Полный пайплайн от EDA до оценки работает на GPU 6 ГБ</a:t>
+            </a:r>
+          </a:p>
+        </p:txBody>
+      </p:sp>
+      <p:sp>
+        <p:nvSpPr>
+          <p:cNvPr id="5" name="TextBox 4"/>
+          <p:cNvSpPr txBox="1"/>
+          <p:nvPr/>
+        </p:nvSpPr>
+        <p:spPr>
+          <a:xfrm>
+            <a:off x="914400" y="2240280"/>
+            <a:ext cx="9601200" cy="457200"/>
+          </a:xfrm>
+          <a:prstGeom prst="rect">
+            <a:avLst/>
+          </a:prstGeom>
+          <a:noFill/>
+        </p:spPr>
+        <p:txBody>
+          <a:bodyPr wrap="square">
+            <a:spAutoFit/>
+          </a:bodyPr>
+          <a:lstStyle/>
+          <a:p>
+            <a:pPr algn="l">
+              <a:defRPr sz="1800" b="0">
+                <a:solidFill>
+                  <a:srgbClr val="FFFFFF"/>
+                </a:solidFill>
+              </a:defRPr>
+            </a:pPr>
+            <a:r>
+              <a:t>✓ QLoRA позволяет fine-tune VLM без серверного оборудования</a:t>
+            </a:r>
+          </a:p>
+        </p:txBody>
+      </p:sp>
+      <p:sp>
+        <p:nvSpPr>
+          <p:cNvPr id="6" name="TextBox 5"/>
+          <p:cNvSpPr txBox="1"/>
+          <p:nvPr/>
+        </p:nvSpPr>
+        <p:spPr>
+          <a:xfrm>
+            <a:off x="914400" y="2743200"/>
+            <a:ext cx="9601200" cy="457200"/>
+          </a:xfrm>
+          <a:prstGeom prst="rect">
+            <a:avLst/>
+          </a:prstGeom>
+          <a:noFill/>
+        </p:spPr>
+        <p:txBody>
+          <a:bodyPr wrap="square">
+            <a:spAutoFit/>
+          </a:bodyPr>
+          <a:lstStyle/>
+          <a:p>
+            <a:pPr algn="l">
+              <a:defRPr sz="1800" b="0">
+                <a:solidFill>
+                  <a:srgbClr val="FFFFFF"/>
+                </a:solidFill>
+              </a:defRPr>
+            </a:pPr>
+            <a:r>
+              <a:t>✓ Все данные и модели — открытые от VK, проект воспроизводим</a:t>
+            </a:r>
+          </a:p>
+        </p:txBody>
+      </p:sp>
+      <p:sp>
+        <p:nvSpPr>
+          <p:cNvPr id="7" name="TextBox 6"/>
+          <p:cNvSpPr txBox="1"/>
+          <p:nvPr/>
+        </p:nvSpPr>
+        <p:spPr>
+          <a:xfrm>
+            <a:off x="914400" y="3246120"/>
+            <a:ext cx="9601200" cy="457200"/>
+          </a:xfrm>
+          <a:prstGeom prst="rect">
+            <a:avLst/>
+          </a:prstGeom>
+          <a:noFill/>
+        </p:spPr>
+        <p:txBody>
+          <a:bodyPr wrap="square">
+            <a:spAutoFit/>
+          </a:bodyPr>
+          <a:lstStyle/>
+          <a:p>
+            <a:pPr algn="l">
+              <a:defRPr sz="1800" b="0">
+                <a:solidFill>
+                  <a:srgbClr val="FFFFFF"/>
+                </a:solidFill>
+              </a:defRPr>
+            </a:pPr>
+            <a:r>
+              <a:t>✓ Сравнение base vs fine-tuned на двух бенчмарках</a:t>
+            </a:r>
+          </a:p>
+        </p:txBody>
+      </p:sp>
+      <p:sp>
+        <p:nvSpPr>
+          <p:cNvPr id="8" name="TextBox 7"/>
+          <p:cNvSpPr txBox="1"/>
+          <p:nvPr/>
+        </p:nvSpPr>
+        <p:spPr>
+          <a:xfrm>
+            <a:off x="731520" y="4023360"/>
+            <a:ext cx="10058400" cy="457200"/>
+          </a:xfrm>
+          <a:prstGeom prst="rect">
+            <a:avLst/>
+          </a:prstGeom>
+          <a:noFill/>
+        </p:spPr>
+        <p:txBody>
+          <a:bodyPr wrap="square">
+            <a:spAutoFit/>
+          </a:bodyPr>
+          <a:lstStyle/>
+          <a:p>
+            <a:pPr algn="l">
+              <a:defRPr sz="2000" b="1">
                 <a:solidFill>
                   <a:srgbClr val="4FC3F7"/>
                 </a:solidFill>
               </a:defRPr>
             </a:pPr>
             <a:r>
-              <a:t>Модель</a:t>
-            </a:r>
-          </a:p>
-        </p:txBody>
-      </p:sp>
-      <p:sp>
-        <p:nvSpPr>
-          <p:cNvPr id="5" name="TextBox 4"/>
-          <p:cNvSpPr txBox="1"/>
-          <p:nvPr/>
-        </p:nvSpPr>
-        <p:spPr>
-          <a:xfrm>
-            <a:off x="4572000" y="2011680"/>
-            <a:ext cx="2743200" cy="365760"/>
-          </a:xfrm>
-          <a:prstGeom prst="rect">
-            <a:avLst/>
-          </a:prstGeom>
-          <a:noFill/>
-        </p:spPr>
-        <p:txBody>
-          <a:bodyPr wrap="square">
-            <a:spAutoFit/>
-          </a:bodyPr>
-          <a:lstStyle/>
-          <a:p>
-            <a:pPr algn="l">
-              <a:defRPr sz="1600" b="1">
-                <a:solidFill>
-                  <a:srgbClr val="4FC3F7"/>
-                </a:solidFill>
-              </a:defRPr>
-            </a:pPr>
-            <a:r>
-              <a:t>GQA-ru (accuracy)</a:t>
-            </a:r>
-          </a:p>
-        </p:txBody>
-      </p:sp>
-      <p:sp>
-        <p:nvSpPr>
-          <p:cNvPr id="6" name="TextBox 5"/>
-          <p:cNvSpPr txBox="1"/>
-          <p:nvPr/>
-        </p:nvSpPr>
-        <p:spPr>
-          <a:xfrm>
-            <a:off x="7772400" y="2011680"/>
-            <a:ext cx="3200400" cy="365760"/>
-          </a:xfrm>
-          <a:prstGeom prst="rect">
-            <a:avLst/>
-          </a:prstGeom>
-          <a:noFill/>
-        </p:spPr>
-        <p:txBody>
-          <a:bodyPr wrap="square">
-            <a:spAutoFit/>
-          </a:bodyPr>
-          <a:lstStyle/>
-          <a:p>
-            <a:pPr algn="l">
-              <a:defRPr sz="1600" b="1">
-                <a:solidFill>
-                  <a:srgbClr val="4FC3F7"/>
-                </a:solidFill>
-              </a:defRPr>
-            </a:pPr>
-            <a:r>
-              <a:t>MMBench-ru (accuracy)</a:t>
-            </a:r>
-          </a:p>
-        </p:txBody>
-      </p:sp>
-      <p:sp>
-        <p:nvSpPr>
-          <p:cNvPr id="7" name="TextBox 6"/>
-          <p:cNvSpPr txBox="1"/>
-          <p:nvPr/>
-        </p:nvSpPr>
-        <p:spPr>
-          <a:xfrm>
-            <a:off x="731520" y="2468880"/>
-            <a:ext cx="3657600" cy="365760"/>
-          </a:xfrm>
-          <a:prstGeom prst="rect">
-            <a:avLst/>
-          </a:prstGeom>
-          <a:noFill/>
-        </p:spPr>
-        <p:txBody>
-          <a:bodyPr wrap="square">
-            <a:spAutoFit/>
-          </a:bodyPr>
-          <a:lstStyle/>
-          <a:p>
-            <a:pPr algn="l">
-              <a:defRPr sz="1600" b="0">
-                <a:solidFill>
-                  <a:srgbClr val="FFFFFF"/>
-                </a:solidFill>
-              </a:defRPr>
-            </a:pPr>
-            <a:r>
-              <a:t>Base (без fine-tuning)</a:t>
-            </a:r>
-          </a:p>
-        </p:txBody>
-      </p:sp>
-      <p:sp>
-        <p:nvSpPr>
-          <p:cNvPr id="8" name="TextBox 7"/>
-          <p:cNvSpPr txBox="1"/>
-          <p:nvPr/>
-        </p:nvSpPr>
-        <p:spPr>
-          <a:xfrm>
-            <a:off x="4572000" y="2468880"/>
-            <a:ext cx="2743200" cy="365760"/>
-          </a:xfrm>
-          <a:prstGeom prst="rect">
-            <a:avLst/>
-          </a:prstGeom>
-          <a:noFill/>
-        </p:spPr>
-        <p:txBody>
-          <a:bodyPr wrap="square">
-            <a:spAutoFit/>
-          </a:bodyPr>
-          <a:lstStyle/>
-          <a:p>
-            <a:pPr algn="l">
-              <a:defRPr sz="1600" b="0">
+              <a:t>Направления улучшения:</a:t>
+            </a:r>
+          </a:p>
+        </p:txBody>
+      </p:sp>
+      <p:sp>
+        <p:nvSpPr>
+          <p:cNvPr id="9" name="TextBox 8"/>
+          <p:cNvSpPr txBox="1"/>
+          <p:nvPr/>
+        </p:nvSpPr>
+        <p:spPr>
+          <a:xfrm>
+            <a:off x="914400" y="4572000"/>
+            <a:ext cx="9601200" cy="457200"/>
+          </a:xfrm>
+          <a:prstGeom prst="rect">
+            <a:avLst/>
+          </a:prstGeom>
+          <a:noFill/>
+        </p:spPr>
+        <p:txBody>
+          <a:bodyPr wrap="square">
+            <a:spAutoFit/>
+          </a:bodyPr>
+          <a:lstStyle/>
+          <a:p>
+            <a:pPr algn="l">
+              <a:defRPr sz="1800" b="0">
                 <a:solidFill>
                   <a:srgbClr val="E0E0E0"/>
                 </a:solidFill>
               </a:defRPr>
             </a:pPr>
             <a:r>
-              <a:t>0.4700 (47/100)</a:t>
-            </a:r>
-          </a:p>
-        </p:txBody>
-      </p:sp>
-      <p:sp>
-        <p:nvSpPr>
-          <p:cNvPr id="9" name="TextBox 8"/>
-          <p:cNvSpPr txBox="1"/>
-          <p:nvPr/>
-        </p:nvSpPr>
-        <p:spPr>
-          <a:xfrm>
-            <a:off x="7772400" y="2468880"/>
-            <a:ext cx="3200400" cy="365760"/>
-          </a:xfrm>
-          <a:prstGeom prst="rect">
-            <a:avLst/>
-          </a:prstGeom>
-          <a:noFill/>
-        </p:spPr>
-        <p:txBody>
-          <a:bodyPr wrap="square">
-            <a:spAutoFit/>
-          </a:bodyPr>
-          <a:lstStyle/>
-          <a:p>
-            <a:pPr algn="l">
-              <a:defRPr sz="1600" b="0">
+              <a:t>→ Обучение с изображениями (train_balanced_images split)</a:t>
+            </a:r>
+          </a:p>
+        </p:txBody>
+      </p:sp>
+      <p:sp>
+        <p:nvSpPr>
+          <p:cNvPr id="10" name="TextBox 9"/>
+          <p:cNvSpPr txBox="1"/>
+          <p:nvPr/>
+        </p:nvSpPr>
+        <p:spPr>
+          <a:xfrm>
+            <a:off x="914400" y="5074920"/>
+            <a:ext cx="9601200" cy="457200"/>
+          </a:xfrm>
+          <a:prstGeom prst="rect">
+            <a:avLst/>
+          </a:prstGeom>
+          <a:noFill/>
+        </p:spPr>
+        <p:txBody>
+          <a:bodyPr wrap="square">
+            <a:spAutoFit/>
+          </a:bodyPr>
+          <a:lstStyle/>
+          <a:p>
+            <a:pPr algn="l">
+              <a:defRPr sz="1800" b="0">
                 <a:solidFill>
                   <a:srgbClr val="E0E0E0"/>
                 </a:solidFill>
               </a:defRPr>
             </a:pPr>
             <a:r>
-              <a:t>0.5700 (57/100)</a:t>
-            </a:r>
-          </a:p>
-        </p:txBody>
-      </p:sp>
-      <p:sp>
-        <p:nvSpPr>
-          <p:cNvPr id="10" name="TextBox 9"/>
-          <p:cNvSpPr txBox="1"/>
-          <p:nvPr/>
-        </p:nvSpPr>
-        <p:spPr>
-          <a:xfrm>
-            <a:off x="731520" y="2926080"/>
-            <a:ext cx="3657600" cy="365760"/>
-          </a:xfrm>
-          <a:prstGeom prst="rect">
-            <a:avLst/>
-          </a:prstGeom>
-          <a:noFill/>
-        </p:spPr>
-        <p:txBody>
-          <a:bodyPr wrap="square">
-            <a:spAutoFit/>
-          </a:bodyPr>
-          <a:lstStyle/>
-          <a:p>
-            <a:pPr algn="l">
-              <a:defRPr sz="1600" b="1">
-                <a:solidFill>
-                  <a:srgbClr val="4CAF50"/>
-                </a:solidFill>
-              </a:defRPr>
-            </a:pPr>
-            <a:r>
-              <a:t>Fine-tuned (QLoRA)</a:t>
+              <a:t>→ Увеличение обучающих данных (40k вместо 2000)</a:t>
             </a:r>
           </a:p>
         </p:txBody>
@@ -6076,29 +6200,29 @@
         </p:nvSpPr>
         <p:spPr>
           <a:xfrm>
-            <a:off x="4572000" y="2926080"/>
-            <a:ext cx="2743200" cy="365760"/>
-          </a:xfrm>
-          <a:prstGeom prst="rect">
-            <a:avLst/>
-          </a:prstGeom>
-          <a:noFill/>
-        </p:spPr>
-        <p:txBody>
-          <a:bodyPr wrap="square">
-            <a:spAutoFit/>
-          </a:bodyPr>
-          <a:lstStyle/>
-          <a:p>
-            <a:pPr algn="l">
-              <a:defRPr sz="1600" b="0">
-                <a:solidFill>
-                  <a:srgbClr val="4CAF50"/>
-                </a:solidFill>
-              </a:defRPr>
-            </a:pPr>
-            <a:r>
-              <a:t>0.4600 (46/100)</a:t>
+            <a:off x="914400" y="5577840"/>
+            <a:ext cx="9601200" cy="457200"/>
+          </a:xfrm>
+          <a:prstGeom prst="rect">
+            <a:avLst/>
+          </a:prstGeom>
+          <a:noFill/>
+        </p:spPr>
+        <p:txBody>
+          <a:bodyPr wrap="square">
+            <a:spAutoFit/>
+          </a:bodyPr>
+          <a:lstStyle/>
+          <a:p>
+            <a:pPr algn="l">
+              <a:defRPr sz="1800" b="0">
+                <a:solidFill>
+                  <a:srgbClr val="E0E0E0"/>
+                </a:solidFill>
+              </a:defRPr>
+            </a:pPr>
+            <a:r>
+              <a:t>→ Добавление LLaVA-Instruct-ru в обучающий набор</a:t>
             </a:r>
           </a:p>
         </p:txBody>
@@ -6111,169 +6235,29 @@
         </p:nvSpPr>
         <p:spPr>
           <a:xfrm>
-            <a:off x="7772400" y="2926080"/>
-            <a:ext cx="3200400" cy="365760"/>
-          </a:xfrm>
-          <a:prstGeom prst="rect">
-            <a:avLst/>
-          </a:prstGeom>
-          <a:noFill/>
-        </p:spPr>
-        <p:txBody>
-          <a:bodyPr wrap="square">
-            <a:spAutoFit/>
-          </a:bodyPr>
-          <a:lstStyle/>
-          <a:p>
-            <a:pPr algn="l">
-              <a:defRPr sz="1600" b="0">
-                <a:solidFill>
-                  <a:srgbClr val="4CAF50"/>
-                </a:solidFill>
-              </a:defRPr>
-            </a:pPr>
-            <a:r>
-              <a:t>0.5700 (57/100)</a:t>
-            </a:r>
-          </a:p>
-        </p:txBody>
-      </p:sp>
-      <p:sp>
-        <p:nvSpPr>
-          <p:cNvPr id="13" name="TextBox 12"/>
-          <p:cNvSpPr txBox="1"/>
-          <p:nvPr/>
-        </p:nvSpPr>
-        <p:spPr>
-          <a:xfrm>
-            <a:off x="731520" y="3840480"/>
-            <a:ext cx="10058400" cy="457200"/>
-          </a:xfrm>
-          <a:prstGeom prst="rect">
-            <a:avLst/>
-          </a:prstGeom>
-          <a:noFill/>
-        </p:spPr>
-        <p:txBody>
-          <a:bodyPr wrap="square">
-            <a:spAutoFit/>
-          </a:bodyPr>
-          <a:lstStyle/>
-          <a:p>
-            <a:pPr algn="l">
-              <a:defRPr sz="1600" b="0">
+            <a:off x="914400" y="6080760"/>
+            <a:ext cx="9601200" cy="457200"/>
+          </a:xfrm>
+          <a:prstGeom prst="rect">
+            <a:avLst/>
+          </a:prstGeom>
+          <a:noFill/>
+        </p:spPr>
+        <p:txBody>
+          <a:bodyPr wrap="square">
+            <a:spAutoFit/>
+          </a:bodyPr>
+          <a:lstStyle/>
+          <a:p>
+            <a:pPr algn="l">
+              <a:defRPr sz="1800" b="0">
                 <a:solidFill>
                   <a:srgbClr val="E0E0E0"/>
                 </a:solidFill>
               </a:defRPr>
             </a:pPr>
             <a:r>
-              <a:t>Train loss: 6.34 (9.3 → 5.1 за 100 шагов)</a:t>
-            </a:r>
-          </a:p>
-        </p:txBody>
-      </p:sp>
-      <p:sp>
-        <p:nvSpPr>
-          <p:cNvPr id="14" name="TextBox 13"/>
-          <p:cNvSpPr txBox="1"/>
-          <p:nvPr/>
-        </p:nvSpPr>
-        <p:spPr>
-          <a:xfrm>
-            <a:off x="731520" y="4389120"/>
-            <a:ext cx="10058400" cy="457200"/>
-          </a:xfrm>
-          <a:prstGeom prst="rect">
-            <a:avLst/>
-          </a:prstGeom>
-          <a:noFill/>
-        </p:spPr>
-        <p:txBody>
-          <a:bodyPr wrap="square">
-            <a:spAutoFit/>
-          </a:bodyPr>
-          <a:lstStyle/>
-          <a:p>
-            <a:pPr algn="l">
-              <a:defRPr sz="1600" b="0">
-                <a:solidFill>
-                  <a:srgbClr val="E0E0E0"/>
-                </a:solidFill>
-              </a:defRPr>
-            </a:pPr>
-            <a:r>
-              <a:t>VRAM: ~2.1 ГБ из 6 ГБ (RTX 4050)</a:t>
-            </a:r>
-          </a:p>
-        </p:txBody>
-      </p:sp>
-      <p:sp>
-        <p:nvSpPr>
-          <p:cNvPr id="15" name="TextBox 14"/>
-          <p:cNvSpPr txBox="1"/>
-          <p:nvPr/>
-        </p:nvSpPr>
-        <p:spPr>
-          <a:xfrm>
-            <a:off x="731520" y="4937760"/>
-            <a:ext cx="10058400" cy="457200"/>
-          </a:xfrm>
-          <a:prstGeom prst="rect">
-            <a:avLst/>
-          </a:prstGeom>
-          <a:noFill/>
-        </p:spPr>
-        <p:txBody>
-          <a:bodyPr wrap="square">
-            <a:spAutoFit/>
-          </a:bodyPr>
-          <a:lstStyle/>
-          <a:p>
-            <a:pPr algn="l">
-              <a:defRPr sz="1600" b="0">
-                <a:solidFill>
-                  <a:srgbClr val="E0E0E0"/>
-                </a:solidFill>
-              </a:defRPr>
-            </a:pPr>
-            <a:r>
-              <a:t>Обучающих примеров: 2000 из GQA-ru</a:t>
-            </a:r>
-          </a:p>
-        </p:txBody>
-      </p:sp>
-      <p:sp>
-        <p:nvSpPr>
-          <p:cNvPr id="16" name="TextBox 15"/>
-          <p:cNvSpPr txBox="1"/>
-          <p:nvPr/>
-        </p:nvSpPr>
-        <p:spPr>
-          <a:xfrm>
-            <a:off x="731520" y="5486400"/>
-            <a:ext cx="10058400" cy="457200"/>
-          </a:xfrm>
-          <a:prstGeom prst="rect">
-            <a:avLst/>
-          </a:prstGeom>
-          <a:noFill/>
-        </p:spPr>
-        <p:txBody>
-          <a:bodyPr wrap="square">
-            <a:spAutoFit/>
-          </a:bodyPr>
-          <a:lstStyle/>
-          <a:p>
-            <a:pPr algn="l">
-              <a:defRPr sz="1600" b="0">
-                <a:solidFill>
-                  <a:srgbClr val="E0E0E0"/>
-                </a:solidFill>
-              </a:defRPr>
-            </a:pPr>
-            <a:r>
-              <a:t>Trainable params: 19.6M (0.78%) из 2.5B</a:t>
+              <a:t>→ Grid search гиперпараметров (LoRA rank, LR, steps)</a:t>
             </a:r>
           </a:p>
         </p:txBody>
@@ -6287,424 +6271,6 @@
 </file>
 
 <file path=ppt/slides/slide8.xml><?xml version="1.0" encoding="utf-8"?>
-<p:sld xmlns:a="http://schemas.openxmlformats.org/drawingml/2006/main" xmlns:r="http://schemas.openxmlformats.org/officeDocument/2006/relationships" xmlns:p="http://schemas.openxmlformats.org/presentationml/2006/main">
-  <p:cSld>
-    <p:bg>
-      <p:bgPr>
-        <a:solidFill>
-          <a:srgbClr val="1A1A2E"/>
-        </a:solidFill>
-        <a:effectLst/>
-      </p:bgPr>
-    </p:bg>
-    <p:spTree>
-      <p:nvGrpSpPr>
-        <p:cNvPr id="1" name=""/>
-        <p:cNvGrpSpPr/>
-        <p:nvPr/>
-      </p:nvGrpSpPr>
-      <p:grpSpPr>
-        <a:xfrm>
-          <a:off x="0" y="0"/>
-          <a:ext cx="0" cy="0"/>
-          <a:chOff x="0" y="0"/>
-          <a:chExt cx="0" cy="0"/>
-        </a:xfrm>
-      </p:grpSpPr>
-      <p:sp>
-        <p:nvSpPr>
-          <p:cNvPr id="2" name="TextBox 1"/>
-          <p:cNvSpPr txBox="1"/>
-          <p:nvPr/>
-        </p:nvSpPr>
-        <p:spPr>
-          <a:xfrm>
-            <a:off x="457200" y="274320"/>
-            <a:ext cx="10972800" cy="731520"/>
-          </a:xfrm>
-          <a:prstGeom prst="rect">
-            <a:avLst/>
-          </a:prstGeom>
-          <a:noFill/>
-        </p:spPr>
-        <p:txBody>
-          <a:bodyPr wrap="square">
-            <a:spAutoFit/>
-          </a:bodyPr>
-          <a:lstStyle/>
-          <a:p>
-            <a:pPr algn="l">
-              <a:defRPr sz="3200" b="1">
-                <a:solidFill>
-                  <a:srgbClr val="4FC3F7"/>
-                </a:solidFill>
-              </a:defRPr>
-            </a:pPr>
-            <a:r>
-              <a:t>Выводы и направления развития</a:t>
-            </a:r>
-          </a:p>
-        </p:txBody>
-      </p:sp>
-      <p:sp>
-        <p:nvSpPr>
-          <p:cNvPr id="3" name="TextBox 2"/>
-          <p:cNvSpPr txBox="1"/>
-          <p:nvPr/>
-        </p:nvSpPr>
-        <p:spPr>
-          <a:xfrm>
-            <a:off x="731520" y="1188720"/>
-            <a:ext cx="10058400" cy="457200"/>
-          </a:xfrm>
-          <a:prstGeom prst="rect">
-            <a:avLst/>
-          </a:prstGeom>
-          <a:noFill/>
-        </p:spPr>
-        <p:txBody>
-          <a:bodyPr wrap="square">
-            <a:spAutoFit/>
-          </a:bodyPr>
-          <a:lstStyle/>
-          <a:p>
-            <a:pPr algn="l">
-              <a:defRPr sz="2000" b="1">
-                <a:solidFill>
-                  <a:srgbClr val="4CAF50"/>
-                </a:solidFill>
-              </a:defRPr>
-            </a:pPr>
-            <a:r>
-              <a:t>Достижения:</a:t>
-            </a:r>
-          </a:p>
-        </p:txBody>
-      </p:sp>
-      <p:sp>
-        <p:nvSpPr>
-          <p:cNvPr id="4" name="TextBox 3"/>
-          <p:cNvSpPr txBox="1"/>
-          <p:nvPr/>
-        </p:nvSpPr>
-        <p:spPr>
-          <a:xfrm>
-            <a:off x="914400" y="1737360"/>
-            <a:ext cx="9601200" cy="457200"/>
-          </a:xfrm>
-          <a:prstGeom prst="rect">
-            <a:avLst/>
-          </a:prstGeom>
-          <a:noFill/>
-        </p:spPr>
-        <p:txBody>
-          <a:bodyPr wrap="square">
-            <a:spAutoFit/>
-          </a:bodyPr>
-          <a:lstStyle/>
-          <a:p>
-            <a:pPr algn="l">
-              <a:defRPr sz="1800" b="0">
-                <a:solidFill>
-                  <a:srgbClr val="FFFFFF"/>
-                </a:solidFill>
-              </a:defRPr>
-            </a:pPr>
-            <a:r>
-              <a:t>✓ Полный пайплайн от EDA до оценки работает на GPU 6 ГБ</a:t>
-            </a:r>
-          </a:p>
-        </p:txBody>
-      </p:sp>
-      <p:sp>
-        <p:nvSpPr>
-          <p:cNvPr id="5" name="TextBox 4"/>
-          <p:cNvSpPr txBox="1"/>
-          <p:nvPr/>
-        </p:nvSpPr>
-        <p:spPr>
-          <a:xfrm>
-            <a:off x="914400" y="2240280"/>
-            <a:ext cx="9601200" cy="457200"/>
-          </a:xfrm>
-          <a:prstGeom prst="rect">
-            <a:avLst/>
-          </a:prstGeom>
-          <a:noFill/>
-        </p:spPr>
-        <p:txBody>
-          <a:bodyPr wrap="square">
-            <a:spAutoFit/>
-          </a:bodyPr>
-          <a:lstStyle/>
-          <a:p>
-            <a:pPr algn="l">
-              <a:defRPr sz="1800" b="0">
-                <a:solidFill>
-                  <a:srgbClr val="FFFFFF"/>
-                </a:solidFill>
-              </a:defRPr>
-            </a:pPr>
-            <a:r>
-              <a:t>✓ QLoRA позволяет fine-tune VLM без серверного оборудования</a:t>
-            </a:r>
-          </a:p>
-        </p:txBody>
-      </p:sp>
-      <p:sp>
-        <p:nvSpPr>
-          <p:cNvPr id="6" name="TextBox 5"/>
-          <p:cNvSpPr txBox="1"/>
-          <p:nvPr/>
-        </p:nvSpPr>
-        <p:spPr>
-          <a:xfrm>
-            <a:off x="914400" y="2743200"/>
-            <a:ext cx="9601200" cy="457200"/>
-          </a:xfrm>
-          <a:prstGeom prst="rect">
-            <a:avLst/>
-          </a:prstGeom>
-          <a:noFill/>
-        </p:spPr>
-        <p:txBody>
-          <a:bodyPr wrap="square">
-            <a:spAutoFit/>
-          </a:bodyPr>
-          <a:lstStyle/>
-          <a:p>
-            <a:pPr algn="l">
-              <a:defRPr sz="1800" b="0">
-                <a:solidFill>
-                  <a:srgbClr val="FFFFFF"/>
-                </a:solidFill>
-              </a:defRPr>
-            </a:pPr>
-            <a:r>
-              <a:t>✓ Все данные и модели — открытые от VK, проект воспроизводим</a:t>
-            </a:r>
-          </a:p>
-        </p:txBody>
-      </p:sp>
-      <p:sp>
-        <p:nvSpPr>
-          <p:cNvPr id="7" name="TextBox 6"/>
-          <p:cNvSpPr txBox="1"/>
-          <p:nvPr/>
-        </p:nvSpPr>
-        <p:spPr>
-          <a:xfrm>
-            <a:off x="914400" y="3246120"/>
-            <a:ext cx="9601200" cy="457200"/>
-          </a:xfrm>
-          <a:prstGeom prst="rect">
-            <a:avLst/>
-          </a:prstGeom>
-          <a:noFill/>
-        </p:spPr>
-        <p:txBody>
-          <a:bodyPr wrap="square">
-            <a:spAutoFit/>
-          </a:bodyPr>
-          <a:lstStyle/>
-          <a:p>
-            <a:pPr algn="l">
-              <a:defRPr sz="1800" b="0">
-                <a:solidFill>
-                  <a:srgbClr val="FFFFFF"/>
-                </a:solidFill>
-              </a:defRPr>
-            </a:pPr>
-            <a:r>
-              <a:t>✓ Сравнение base vs fine-tuned на двух бенчмарках</a:t>
-            </a:r>
-          </a:p>
-        </p:txBody>
-      </p:sp>
-      <p:sp>
-        <p:nvSpPr>
-          <p:cNvPr id="8" name="TextBox 7"/>
-          <p:cNvSpPr txBox="1"/>
-          <p:nvPr/>
-        </p:nvSpPr>
-        <p:spPr>
-          <a:xfrm>
-            <a:off x="731520" y="4023360"/>
-            <a:ext cx="10058400" cy="457200"/>
-          </a:xfrm>
-          <a:prstGeom prst="rect">
-            <a:avLst/>
-          </a:prstGeom>
-          <a:noFill/>
-        </p:spPr>
-        <p:txBody>
-          <a:bodyPr wrap="square">
-            <a:spAutoFit/>
-          </a:bodyPr>
-          <a:lstStyle/>
-          <a:p>
-            <a:pPr algn="l">
-              <a:defRPr sz="2000" b="1">
-                <a:solidFill>
-                  <a:srgbClr val="4FC3F7"/>
-                </a:solidFill>
-              </a:defRPr>
-            </a:pPr>
-            <a:r>
-              <a:t>Направления улучшения:</a:t>
-            </a:r>
-          </a:p>
-        </p:txBody>
-      </p:sp>
-      <p:sp>
-        <p:nvSpPr>
-          <p:cNvPr id="9" name="TextBox 8"/>
-          <p:cNvSpPr txBox="1"/>
-          <p:nvPr/>
-        </p:nvSpPr>
-        <p:spPr>
-          <a:xfrm>
-            <a:off x="914400" y="4572000"/>
-            <a:ext cx="9601200" cy="457200"/>
-          </a:xfrm>
-          <a:prstGeom prst="rect">
-            <a:avLst/>
-          </a:prstGeom>
-          <a:noFill/>
-        </p:spPr>
-        <p:txBody>
-          <a:bodyPr wrap="square">
-            <a:spAutoFit/>
-          </a:bodyPr>
-          <a:lstStyle/>
-          <a:p>
-            <a:pPr algn="l">
-              <a:defRPr sz="1800" b="0">
-                <a:solidFill>
-                  <a:srgbClr val="E0E0E0"/>
-                </a:solidFill>
-              </a:defRPr>
-            </a:pPr>
-            <a:r>
-              <a:t>→ Обучение с изображениями (train_balanced_images split)</a:t>
-            </a:r>
-          </a:p>
-        </p:txBody>
-      </p:sp>
-      <p:sp>
-        <p:nvSpPr>
-          <p:cNvPr id="10" name="TextBox 9"/>
-          <p:cNvSpPr txBox="1"/>
-          <p:nvPr/>
-        </p:nvSpPr>
-        <p:spPr>
-          <a:xfrm>
-            <a:off x="914400" y="5074920"/>
-            <a:ext cx="9601200" cy="457200"/>
-          </a:xfrm>
-          <a:prstGeom prst="rect">
-            <a:avLst/>
-          </a:prstGeom>
-          <a:noFill/>
-        </p:spPr>
-        <p:txBody>
-          <a:bodyPr wrap="square">
-            <a:spAutoFit/>
-          </a:bodyPr>
-          <a:lstStyle/>
-          <a:p>
-            <a:pPr algn="l">
-              <a:defRPr sz="1800" b="0">
-                <a:solidFill>
-                  <a:srgbClr val="E0E0E0"/>
-                </a:solidFill>
-              </a:defRPr>
-            </a:pPr>
-            <a:r>
-              <a:t>→ Увеличение обучающих данных (40k вместо 2000)</a:t>
-            </a:r>
-          </a:p>
-        </p:txBody>
-      </p:sp>
-      <p:sp>
-        <p:nvSpPr>
-          <p:cNvPr id="11" name="TextBox 10"/>
-          <p:cNvSpPr txBox="1"/>
-          <p:nvPr/>
-        </p:nvSpPr>
-        <p:spPr>
-          <a:xfrm>
-            <a:off x="914400" y="5577840"/>
-            <a:ext cx="9601200" cy="457200"/>
-          </a:xfrm>
-          <a:prstGeom prst="rect">
-            <a:avLst/>
-          </a:prstGeom>
-          <a:noFill/>
-        </p:spPr>
-        <p:txBody>
-          <a:bodyPr wrap="square">
-            <a:spAutoFit/>
-          </a:bodyPr>
-          <a:lstStyle/>
-          <a:p>
-            <a:pPr algn="l">
-              <a:defRPr sz="1800" b="0">
-                <a:solidFill>
-                  <a:srgbClr val="E0E0E0"/>
-                </a:solidFill>
-              </a:defRPr>
-            </a:pPr>
-            <a:r>
-              <a:t>→ Добавление LLaVA-Instruct-ru в обучающий набор</a:t>
-            </a:r>
-          </a:p>
-        </p:txBody>
-      </p:sp>
-      <p:sp>
-        <p:nvSpPr>
-          <p:cNvPr id="12" name="TextBox 11"/>
-          <p:cNvSpPr txBox="1"/>
-          <p:nvPr/>
-        </p:nvSpPr>
-        <p:spPr>
-          <a:xfrm>
-            <a:off x="914400" y="6080760"/>
-            <a:ext cx="9601200" cy="457200"/>
-          </a:xfrm>
-          <a:prstGeom prst="rect">
-            <a:avLst/>
-          </a:prstGeom>
-          <a:noFill/>
-        </p:spPr>
-        <p:txBody>
-          <a:bodyPr wrap="square">
-            <a:spAutoFit/>
-          </a:bodyPr>
-          <a:lstStyle/>
-          <a:p>
-            <a:pPr algn="l">
-              <a:defRPr sz="1800" b="0">
-                <a:solidFill>
-                  <a:srgbClr val="E0E0E0"/>
-                </a:solidFill>
-              </a:defRPr>
-            </a:pPr>
-            <a:r>
-              <a:t>→ Grid search гиперпараметров (LoRA rank, LR, steps)</a:t>
-            </a:r>
-          </a:p>
-        </p:txBody>
-      </p:sp>
-    </p:spTree>
-  </p:cSld>
-  <p:clrMapOvr>
-    <a:masterClrMapping/>
-  </p:clrMapOvr>
-</p:sld>
-</file>
-
-<file path=ppt/slides/slide9.xml><?xml version="1.0" encoding="utf-8"?>
 <p:sld xmlns:a="http://schemas.openxmlformats.org/drawingml/2006/main" xmlns:r="http://schemas.openxmlformats.org/officeDocument/2006/relationships" xmlns:p="http://schemas.openxmlformats.org/presentationml/2006/main">
   <p:cSld>
     <p:bg>

</xml_diff>